<commit_message>
fix: Updated both pptx and pdf presentation according to report updates, updated the decision about 28 low performing skus
</commit_message>
<xml_diff>
--- a/Presentation/profit_leak_diagnostic_deck.pptx
+++ b/Presentation/profit_leak_diagnostic_deck.pptx
@@ -1534,7 +1534,7 @@
                 <a:ea typeface="Cambria" pitchFamily="34" charset="-122"/>
                 <a:cs typeface="Cambria" pitchFamily="34" charset="-120"/>
               </a:rPr>
-              <a:t>How 28 Products Are Bleeding $643K Out of a $35M Catalog</a:t>
+              <a:t>What a $35.2M Catalog's Revenue Report Doesn't Show You</a:t>
             </a:r>
             <a:endParaRPr lang="en-US" sz="1800" dirty="0"/>
           </a:p>
@@ -1612,7 +1612,7 @@
                 <a:ea typeface="Calibri" pitchFamily="34" charset="-122"/>
                 <a:cs typeface="Calibri" pitchFamily="34" charset="-120"/>
               </a:rPr>
-              <a:t>DataCo Supply Chain Dataset  ·  180,519 transactions  ·  3 years</a:t>
+              <a:t>Public DataCo Supply Chain Dataset  ·  180,519 order lines  ·  3 years</a:t>
             </a:r>
             <a:endParaRPr lang="en-US" sz="1200" dirty="0"/>
           </a:p>
@@ -1860,7 +1860,7 @@
                 <a:ea typeface="Calibri" pitchFamily="34" charset="-122"/>
                 <a:cs typeface="Calibri" pitchFamily="34" charset="-120"/>
               </a:rPr>
-              <a:t>Cut the 28 underperforming products now.</a:t>
+              <a:t>Protect the core 8 products like they are the business.</a:t>
             </a:r>
             <a:endParaRPr lang="en-US" sz="1300" dirty="0"/>
           </a:p>
@@ -1899,7 +1899,7 @@
                 <a:ea typeface="Calibri" pitchFamily="34" charset="-122"/>
                 <a:cs typeface="Calibri" pitchFamily="34" charset="-120"/>
               </a:rPr>
-              <a:t>Cost: $67,000 in profit. Return: a quarter of operational bandwidth freed immediately. The fastest, lowest risk move available in this entire audit.</a:t>
+              <a:t>Because they are. Lock in supplier terms, prioritize their fulfillment, and stop touching their pricing without a clear reason.</a:t>
             </a:r>
             <a:endParaRPr lang="en-US" sz="1100" dirty="0"/>
           </a:p>
@@ -1997,7 +1997,7 @@
                 <a:ea typeface="Calibri" pitchFamily="34" charset="-122"/>
                 <a:cs typeface="Calibri" pitchFamily="34" charset="-120"/>
               </a:rPr>
-              <a:t>Protect the core 8 products like they are the business.</a:t>
+              <a:t>Fix First Class, or reset its promise.</a:t>
             </a:r>
             <a:endParaRPr lang="en-US" sz="1300" dirty="0"/>
           </a:p>
@@ -2036,7 +2036,7 @@
                 <a:ea typeface="Calibri" pitchFamily="34" charset="-122"/>
                 <a:cs typeface="Calibri" pitchFamily="34" charset="-120"/>
               </a:rPr>
-              <a:t>Because they are. Lock in supplier terms, prioritize their fulfillment, and stop touching their pricing without a clear reason.</a:t>
+              <a:t>A tier that is late on every order is an active liability. Fix the process, or change the promised window to match what is delivered.</a:t>
             </a:r>
             <a:endParaRPr lang="en-US" sz="1100" dirty="0"/>
           </a:p>
@@ -2134,7 +2134,7 @@
                 <a:ea typeface="Calibri" pitchFamily="34" charset="-122"/>
                 <a:cs typeface="Calibri" pitchFamily="34" charset="-120"/>
               </a:rPr>
-              <a:t>Fix First Class shipping or pull it off the menu.</a:t>
+              <a:t>Sort the 28 low performers by cause before cutting.</a:t>
             </a:r>
             <a:endParaRPr lang="en-US" sz="1300" dirty="0"/>
           </a:p>
@@ -2173,7 +2173,7 @@
                 <a:ea typeface="Calibri" pitchFamily="34" charset="-122"/>
                 <a:cs typeface="Calibri" pitchFamily="34" charset="-120"/>
               </a:rPr>
-              <a:t>A shipping tier that fails 100% of the time is not a minor operational hiccup. It is an active liability sitting on every order placed through it.</a:t>
+              <a:t>Retiring all 28 would give up about $67,000 of profit. Keep the new or seasonal, reprice the cost-driven, fix the delivery-driven, and retire only confirmed dead weight.</a:t>
             </a:r>
             <a:endParaRPr lang="en-US" sz="1100" dirty="0"/>
           </a:p>
@@ -2358,7 +2358,7 @@
                 <a:ea typeface="Calibri" pitchFamily="34" charset="-122"/>
                 <a:cs typeface="Calibri" pitchFamily="34" charset="-120"/>
               </a:rPr>
-              <a:t>zeeshanakramds@gmail.com</a:t>
+              <a:t>zeeshanakram1704@gmail.com</a:t>
             </a:r>
             <a:endParaRPr lang="en-US" sz="1000" dirty="0"/>
           </a:p>
@@ -3117,7 +3117,7 @@
                 <a:ea typeface="Calibri" pitchFamily="34" charset="-122"/>
                 <a:cs typeface="Calibri" pitchFamily="34" charset="-120"/>
               </a:rPr>
-              <a:t>Dead-Weight Products</a:t>
+              <a:t>Low Performers</a:t>
             </a:r>
             <a:endParaRPr lang="en-US" sz="1050" dirty="0"/>
           </a:p>
@@ -3419,7 +3419,7 @@
                 <a:ea typeface="Calibri" pitchFamily="34" charset="-122"/>
                 <a:cs typeface="Calibri" pitchFamily="34" charset="-120"/>
               </a:rPr>
-              <a:t>Exposure If Core 8 Slip</a:t>
+              <a:t>Core 8 Stress Test</a:t>
             </a:r>
             <a:endParaRPr lang="en-US" sz="1050" dirty="0"/>
           </a:p>
@@ -3458,7 +3458,7 @@
                 <a:ea typeface="Calibri" pitchFamily="34" charset="-122"/>
                 <a:cs typeface="Calibri" pitchFamily="34" charset="-120"/>
               </a:rPr>
-              <a:t>17% of total profit</a:t>
+              <a:t>Modeled, 17% of profit</a:t>
             </a:r>
             <a:endParaRPr lang="en-US" sz="900" dirty="0"/>
           </a:p>
@@ -3654,7 +3654,7 @@
                 <a:ea typeface="Calibri" pitchFamily="34" charset="-122"/>
                 <a:cs typeface="Calibri" pitchFamily="34" charset="-120"/>
               </a:rPr>
-              <a:t>Just 8 products generate 84.5% of all profit. The other 110 are operational noise riding on their back.</a:t>
+              <a:t>Just 8 products generate 84.5% of all profit. The other 110 together earn about $590K.</a:t>
             </a:r>
             <a:endParaRPr lang="en-US" sz="1100" dirty="0"/>
           </a:p>
@@ -3752,7 +3752,7 @@
                 <a:ea typeface="Calibri" pitchFamily="34" charset="-122"/>
                 <a:cs typeface="Calibri" pitchFamily="34" charset="-120"/>
               </a:rPr>
-              <a:t>28 products generate only 2.2% of revenue while still consuming real warehouse space and customer service hours.</a:t>
+              <a:t>28 products generate only 2.2% of revenue and about $67K of profit. Sort them by cause before cutting any.</a:t>
             </a:r>
             <a:endParaRPr lang="en-US" sz="1100" dirty="0"/>
           </a:p>
@@ -3948,7 +3948,7 @@
                 <a:ea typeface="Calibri" pitchFamily="34" charset="-122"/>
                 <a:cs typeface="Calibri" pitchFamily="34" charset="-120"/>
               </a:rPr>
-              <a:t>Revenue and profit moved sideways for nearly three years, then collapsed together in the same month. That is what happens when a fragile supply chain finally runs out of room.</a:t>
+              <a:t>44 products sell far better than they earn. The SOLE E35 Elliptical ranks 36th by revenue and last by profit.</a:t>
             </a:r>
             <a:endParaRPr lang="en-US" sz="1100" dirty="0"/>
           </a:p>
@@ -4716,7 +4716,7 @@
                 <a:ea typeface="Calibri" pitchFamily="34" charset="-122"/>
                 <a:cs typeface="Calibri" pitchFamily="34" charset="-120"/>
               </a:rPr>
-              <a:t>Weak margin and high delivery failure. 28 products, 24% of the catalog.</a:t>
+              <a:t>Weak margin and high delivery failure. 28 products, 24% of the catalog. Review by cause before cutting.</a:t>
             </a:r>
             <a:endParaRPr lang="en-US" sz="1050" dirty="0"/>
           </a:p>
@@ -4958,7 +4958,7 @@
                 <a:ea typeface="Calibri" pitchFamily="34" charset="-122"/>
                 <a:cs typeface="Calibri" pitchFamily="34" charset="-120"/>
               </a:rPr>
-              <a:t>The SOLE E35 Elliptical ranks 36th out of 118 products by revenue. In profit, it ranks dead last. It loses money on every order while showing up as a respectable mid-tier seller on any standard sales report.</a:t>
+              <a:t>The SOLE E35 Elliptical ranks 36th out of 118 products by revenue. In profit, it ranks dead last. It is net negative over three years while showing up as a respectable mid-tier seller on any standard sales report.</a:t>
             </a:r>
             <a:endParaRPr lang="en-US" sz="1250" dirty="0"/>
           </a:p>
@@ -5109,7 +5109,7 @@
                 <a:ea typeface="Calibri" pitchFamily="34" charset="-122"/>
                 <a:cs typeface="Calibri" pitchFamily="34" charset="-120"/>
               </a:rPr>
-              <a:t>products show this exact pattern. If decisions in this business are made off a revenue leaderboard, they are being made off the wrong list entirely.</a:t>
+              <a:t>products show this pattern. A revenue leaderboard ranks them higher than their profit deserves.</a:t>
             </a:r>
             <a:endParaRPr lang="en-US" sz="1100" dirty="0"/>
           </a:p>
@@ -5148,7 +5148,7 @@
                 <a:ea typeface="Calibri" pitchFamily="34" charset="-122"/>
                 <a:cs typeface="Calibri" pitchFamily="34" charset="-120"/>
               </a:rPr>
-              <a:t>SOLE E35 and SOLE E25 Ellipticals are net negative across their entire three year history. Not one bad order. Three years of losing money every time they sell.</a:t>
+              <a:t>SOLE E35 and SOLE E25 Ellipticals are net negative across their entire three year history, not just in a bad month.</a:t>
             </a:r>
             <a:endParaRPr lang="en-US" sz="1050" dirty="0"/>
           </a:p>
@@ -5614,7 +5614,7 @@
                 <a:ea typeface="Calibri" pitchFamily="34" charset="-122"/>
                 <a:cs typeface="Calibri" pitchFamily="34" charset="-120"/>
               </a:rPr>
-              <a:t>Customers paying the most for speed are getting the worst experience this business offers. That is not a logistics footnote. It is a refund risk and a trust problem sitting quietly inside the fulfillment numbers.</a:t>
+              <a:t>Customers paying the most for speed get the least reliable delivery. A 100% rate with a one-day average gap suggests the promised window may be mis-set. Check the delay distribution to confirm.</a:t>
             </a:r>
             <a:endParaRPr lang="en-US" sz="1200" dirty="0"/>
           </a:p>
@@ -6001,7 +6001,7 @@
                 <a:ea typeface="Cambria" pitchFamily="34" charset="-122"/>
                 <a:cs typeface="Cambria" pitchFamily="34" charset="-120"/>
               </a:rPr>
-              <a:t>Zero</a:t>
+              <a:t>p = 0.73</a:t>
             </a:r>
             <a:endParaRPr lang="en-US" sz="1900" dirty="0"/>
           </a:p>
@@ -6040,7 +6040,7 @@
                 <a:ea typeface="Calibri" pitchFamily="34" charset="-122"/>
                 <a:cs typeface="Calibri" pitchFamily="34" charset="-120"/>
               </a:rPr>
-              <a:t>statistically confirmed link between discount depth and margin</a:t>
+              <a:t>no significant link between discount depth and margin</a:t>
             </a:r>
             <a:endParaRPr lang="en-US" sz="950" dirty="0"/>
           </a:p>
@@ -6264,7 +6264,7 @@
                 <a:ea typeface="Calibri" pitchFamily="34" charset="-122"/>
                 <a:cs typeface="Calibri" pitchFamily="34" charset="-120"/>
               </a:rPr>
-              <a:t>of those discounted top-seller orders still lose money</a:t>
+              <a:t>of the top 4 products' orders still lose money</a:t>
             </a:r>
             <a:endParaRPr lang="en-US" sz="950" dirty="0"/>
           </a:p>
@@ -6303,7 +6303,7 @@
                 <a:ea typeface="Calibri" pitchFamily="34" charset="-122"/>
                 <a:cs typeface="Calibri" pitchFamily="34" charset="-120"/>
               </a:rPr>
-              <a:t>The top of this catalog is not winning on merit. It is winning on subsidy, and there is no quick pricing fix waiting to be pulled.</a:t>
+              <a:t>The top 4 earn the most in dollars, yet 94.4% of their orders carry a discount. Discount depth does not explain which products earn less.</a:t>
             </a:r>
             <a:endParaRPr lang="en-US" sz="1150" dirty="0"/>
           </a:p>
@@ -6807,7 +6807,7 @@
                 <a:ea typeface="Cambria" pitchFamily="34" charset="-122"/>
                 <a:cs typeface="Cambria" pitchFamily="34" charset="-120"/>
               </a:rPr>
-              <a:t>What Happens If Nothing Changes</a:t>
+              <a:t>What Each Scenario Costs</a:t>
             </a:r>
             <a:endParaRPr lang="en-US" sz="3000" dirty="0"/>
           </a:p>
@@ -6955,7 +6955,7 @@
                 <a:ea typeface="Calibri" pitchFamily="34" charset="-122"/>
                 <a:cs typeface="Calibri" pitchFamily="34" charset="-120"/>
               </a:rPr>
-              <a:t>LOWEST RISK</a:t>
+              <a:t>A DECISION</a:t>
             </a:r>
             <a:endParaRPr lang="en-US" sz="900" dirty="0"/>
           </a:p>
@@ -6994,7 +6994,7 @@
                 <a:ea typeface="Calibri" pitchFamily="34" charset="-122"/>
                 <a:cs typeface="Calibri" pitchFamily="34" charset="-120"/>
               </a:rPr>
-              <a:t>Cutting the 28 Weak Products</a:t>
+              <a:t>Retiring the 28 Low Performers</a:t>
             </a:r>
             <a:endParaRPr lang="en-US" sz="1350" dirty="0"/>
           </a:p>
@@ -7033,7 +7033,7 @@
                 <a:ea typeface="Calibri" pitchFamily="34" charset="-122"/>
                 <a:cs typeface="Calibri" pitchFamily="34" charset="-120"/>
               </a:rPr>
-              <a:t>Costs $67,000 in profit and frees up roughly a quarter of operational bandwidth. Low risk, fast return, almost no downside.</a:t>
+              <a:t>Gives up about $67,000 of profit (1.8%). Handling and support savings are not measured here, so review by cause first.</a:t>
             </a:r>
             <a:endParaRPr lang="en-US" sz="950" dirty="0"/>
           </a:p>
@@ -7206,7 +7206,7 @@
                 <a:ea typeface="Calibri" pitchFamily="34" charset="-122"/>
                 <a:cs typeface="Calibri" pitchFamily="34" charset="-120"/>
               </a:rPr>
-              <a:t>Costs $643,000. This is the single largest financial exposure sitting inside this business today.</a:t>
+              <a:t>A modeled 20% margin shock costs $643,000, more than the other 110 products earn combined.</a:t>
             </a:r>
             <a:endParaRPr lang="en-US" sz="950" dirty="0"/>
           </a:p>
@@ -7301,7 +7301,7 @@
                 <a:ea typeface="Calibri" pitchFamily="34" charset="-122"/>
                 <a:cs typeface="Calibri" pitchFamily="34" charset="-120"/>
               </a:rPr>
-              <a:t>ALREADY HAPPENING</a:t>
+              <a:t>DIRECTIONAL ESTIMATE</a:t>
             </a:r>
             <a:endParaRPr lang="en-US" sz="900" dirty="0"/>
           </a:p>
@@ -7340,7 +7340,7 @@
                 <a:ea typeface="Calibri" pitchFamily="34" charset="-122"/>
                 <a:cs typeface="Calibri" pitchFamily="34" charset="-120"/>
               </a:rPr>
-              <a:t>Letting Conditions Compound</a:t>
+              <a:t>If Conditions Compound</a:t>
             </a:r>
             <a:endParaRPr lang="en-US" sz="1350" dirty="0"/>
           </a:p>
@@ -7379,7 +7379,7 @@
                 <a:ea typeface="Calibri" pitchFamily="34" charset="-122"/>
                 <a:cs typeface="Calibri" pitchFamily="34" charset="-120"/>
               </a:rPr>
-              <a:t>More discounting and more late deliveries cost an additional $181,000 in margin erosion. This is already the direction the data is moving.</a:t>
+              <a:t>+10% discount dependency and +15% delivery risk cost about $181,000. A directional estimate, not a forecast.</a:t>
             </a:r>
             <a:endParaRPr lang="en-US" sz="950" dirty="0"/>
           </a:p>
@@ -7568,7 +7568,7 @@
                 <a:ea typeface="Calibri" pitchFamily="34" charset="-122"/>
                 <a:cs typeface="Calibri" pitchFamily="34" charset="-120"/>
               </a:rPr>
-              <a:t>This audit is built on 180,519 real order line transactions spanning three years of operating history, loaded into a structured PostgreSQL warehouse and checked for data quality at every stage before a single chart was built.</a:t>
+              <a:t>This audit is built on 180,519 order lines from the public DataCo dataset, spanning three years, loaded into a structured PostgreSQL warehouse and checked for data quality at every stage before a single chart was built.</a:t>
             </a:r>
             <a:endParaRPr lang="en-US" sz="1300" dirty="0"/>
           </a:p>

</xml_diff>